<commit_message>
feat(templates): add milestone image sequence
</commit_message>
<xml_diff>
--- a/skills/presentation-template-library/skills/artifact-template-jade-annual-brief/assets/reference.pptx
+++ b/skills/presentation-template-library/skills/artifact-template-jade-annual-brief/assets/reference.pptx
@@ -4649,58 +4649,159 @@
       </p:sp>
       <p:sp>
         <p:nvSpPr>
-          <p:cNvPr id="19" name="operating-label-0"/>
-          <p:cNvSpPr txBox="1"/>
-          <p:nvPr/>
-        </p:nvSpPr>
-        <p:spPr>
-          <a:xfrm xmlns:a="http://schemas.openxmlformats.org/drawingml/2006/main">
-            <a:off x="1104900" y="3333750"/>
-            <a:ext cx="1809750" cy="228600"/>
-          </a:xfrm>
-          <a:prstGeom xmlns:a="http://schemas.openxmlformats.org/drawingml/2006/main" prst="rect">
-            <a:avLst/>
-          </a:prstGeom>
-          <a:noFill xmlns:a="http://schemas.openxmlformats.org/drawingml/2006/main"/>
-          <a:ln xmlns:a="http://schemas.openxmlformats.org/drawingml/2006/main" w="0">
-            <a:noFill/>
-          </a:ln>
-        </p:spPr>
-        <p:txBody>
-          <a:bodyPr xmlns:a="http://schemas.openxmlformats.org/drawingml/2006/main" wrap="square" lIns="0" tIns="0" rIns="0" bIns="0" anchor="t"/>
-          <a:lstStyle xmlns:a="http://schemas.openxmlformats.org/drawingml/2006/main"/>
-          <a:p xmlns:a="http://schemas.openxmlformats.org/drawingml/2006/main">
-            <a:r>
-              <a:rPr lang="en-US" sz="1125" b="1">
+          <p:cNvPr id="19" name="event-period-0"/>
+          <p:cNvSpPr txBox="1"/>
+          <p:nvPr/>
+        </p:nvSpPr>
+        <p:spPr>
+          <a:xfrm xmlns:a="http://schemas.openxmlformats.org/drawingml/2006/main">
+            <a:off x="990600" y="3162300"/>
+            <a:ext cx="3181350" cy="323850"/>
+          </a:xfrm>
+          <a:prstGeom xmlns:a="http://schemas.openxmlformats.org/drawingml/2006/main" prst="rect">
+            <a:avLst/>
+          </a:prstGeom>
+          <a:noFill xmlns:a="http://schemas.openxmlformats.org/drawingml/2006/main"/>
+          <a:ln xmlns:a="http://schemas.openxmlformats.org/drawingml/2006/main" w="0">
+            <a:noFill/>
+          </a:ln>
+        </p:spPr>
+        <p:txBody>
+          <a:bodyPr xmlns:a="http://schemas.openxmlformats.org/drawingml/2006/main" wrap="square" lIns="0" tIns="0" rIns="0" bIns="0" anchor="t"/>
+          <a:lstStyle xmlns:a="http://schemas.openxmlformats.org/drawingml/2006/main"/>
+          <a:p xmlns:a="http://schemas.openxmlformats.org/drawingml/2006/main">
+            <a:r>
+              <a:rPr lang="en-US" sz="2100" b="1">
+                <a:solidFill>
+                  <a:srgbClr val="222222"/>
+                </a:solidFill>
+                <a:latin typeface="Tahoma"/>
+                <a:ea typeface="Tahoma"/>
+              </a:rPr>
+              <a:t>2019</a:t>
+            </a:r>
+            <a:endParaRPr lang="en-US"/>
+          </a:p>
+        </p:txBody>
+      </p:sp>
+      <p:sp>
+        <p:nvSpPr>
+          <p:cNvPr id="20" name="event-title-0"/>
+          <p:cNvSpPr txBox="1"/>
+          <p:nvPr/>
+        </p:nvSpPr>
+        <p:spPr>
+          <a:xfrm xmlns:a="http://schemas.openxmlformats.org/drawingml/2006/main">
+            <a:off x="990600" y="3562350"/>
+            <a:ext cx="3181350" cy="247650"/>
+          </a:xfrm>
+          <a:prstGeom xmlns:a="http://schemas.openxmlformats.org/drawingml/2006/main" prst="rect">
+            <a:avLst/>
+          </a:prstGeom>
+          <a:noFill xmlns:a="http://schemas.openxmlformats.org/drawingml/2006/main"/>
+          <a:ln xmlns:a="http://schemas.openxmlformats.org/drawingml/2006/main" w="0">
+            <a:noFill/>
+          </a:ln>
+        </p:spPr>
+        <p:txBody>
+          <a:bodyPr xmlns:a="http://schemas.openxmlformats.org/drawingml/2006/main" wrap="square" lIns="0" tIns="0" rIns="0" bIns="0" anchor="t"/>
+          <a:lstStyle xmlns:a="http://schemas.openxmlformats.org/drawingml/2006/main"/>
+          <a:p xmlns:a="http://schemas.openxmlformats.org/drawingml/2006/main">
+            <a:r>
+              <a:rPr lang="en-US" sz="1275" b="1">
+                <a:solidFill>
+                  <a:srgbClr val="222222"/>
+                </a:solidFill>
+                <a:latin typeface="Tahoma"/>
+                <a:ea typeface="Tahoma"/>
+              </a:rPr>
+              <a:t>First signal</a:t>
+            </a:r>
+            <a:endParaRPr lang="en-US"/>
+          </a:p>
+        </p:txBody>
+      </p:sp>
+      <p:sp>
+        <p:nvSpPr>
+          <p:cNvPr id="21" name="event-text-0"/>
+          <p:cNvSpPr txBox="1"/>
+          <p:nvPr/>
+        </p:nvSpPr>
+        <p:spPr>
+          <a:xfrm xmlns:a="http://schemas.openxmlformats.org/drawingml/2006/main">
+            <a:off x="990600" y="3905250"/>
+            <a:ext cx="3181350" cy="628650"/>
+          </a:xfrm>
+          <a:prstGeom xmlns:a="http://schemas.openxmlformats.org/drawingml/2006/main" prst="rect">
+            <a:avLst/>
+          </a:prstGeom>
+          <a:noFill xmlns:a="http://schemas.openxmlformats.org/drawingml/2006/main"/>
+          <a:ln xmlns:a="http://schemas.openxmlformats.org/drawingml/2006/main" w="0">
+            <a:noFill/>
+          </a:ln>
+        </p:spPr>
+        <p:txBody>
+          <a:bodyPr xmlns:a="http://schemas.openxmlformats.org/drawingml/2006/main" wrap="square" lIns="0" tIns="0" rIns="0" bIns="0" anchor="t"/>
+          <a:lstStyle xmlns:a="http://schemas.openxmlformats.org/drawingml/2006/main"/>
+          <a:p xmlns:a="http://schemas.openxmlformats.org/drawingml/2006/main">
+            <a:r>
+              <a:rPr lang="en-US" sz="1125">
                 <a:solidFill>
                   <a:srgbClr val="8E8D88"/>
                 </a:solidFill>
                 <a:latin typeface="Tahoma"/>
                 <a:ea typeface="Tahoma"/>
               </a:rPr>
-              <a:t>NOW</a:t>
-            </a:r>
-            <a:endParaRPr lang="en-US"/>
-          </a:p>
-        </p:txBody>
-      </p:sp>
-      <p:sp>
-        <p:nvSpPr>
-          <p:cNvPr id="20" name="operating-bar-0"/>
+              <a:t>A small operating change makes the hidden pattern visible.</a:t>
+            </a:r>
+            <a:endParaRPr lang="en-US"/>
+          </a:p>
+        </p:txBody>
+      </p:sp>
+      <p:pic>
+        <p:nvPicPr>
+          <p:cNvPr id="22" name="event-photo-0">
+            <a:extLst xmlns:a="http://schemas.openxmlformats.org/drawingml/2006/main">
+              <a:ext uri="{C183D7F6-B498-43B3-948B-1728B52AA6E4}">
+                <adec:decorative xmlns:adec="http://schemas.microsoft.com/office/drawing/2017/decorative" val="1"/>
+              </a:ext>
+            </a:extLst>
+          </p:cNvPr>
+          <p:cNvPicPr/>
+          <p:nvPr/>
+        </p:nvPicPr>
+        <p:blipFill>
+          <a:blip xmlns:r="http://schemas.openxmlformats.org/officeDocument/2006/relationships" xmlns:a="http://schemas.openxmlformats.org/drawingml/2006/main" r:embed="rIdOfficeKitImage026be3a43029630d_1"/>
+          <a:srcRect xmlns:a="http://schemas.openxmlformats.org/drawingml/2006/main" l="0" t="34001" r="0" b="34001"/>
+          <a:stretch xmlns:a="http://schemas.openxmlformats.org/drawingml/2006/main">
+            <a:fillRect/>
+          </a:stretch>
+        </p:blipFill>
+        <p:spPr>
+          <a:xfrm xmlns:a="http://schemas.openxmlformats.org/drawingml/2006/main">
+            <a:off x="990600" y="4914900"/>
+            <a:ext cx="3181350" cy="1809750"/>
+          </a:xfrm>
+          <a:prstGeom xmlns:a="http://schemas.openxmlformats.org/drawingml/2006/main" prst="rect">
+            <a:avLst/>
+          </a:prstGeom>
+        </p:spPr>
+      </p:pic>
+      <p:sp>
+        <p:nvSpPr>
+          <p:cNvPr id="23" name="event-rule-0"/>
           <p:cNvSpPr/>
           <p:nvPr/>
         </p:nvSpPr>
         <p:spPr>
           <a:xfrm xmlns:a="http://schemas.openxmlformats.org/drawingml/2006/main">
-            <a:off x="1104900" y="3848100"/>
-            <a:ext cx="2095500" cy="323850"/>
-          </a:xfrm>
-          <a:prstGeom xmlns:a="http://schemas.openxmlformats.org/drawingml/2006/main" prst="rect">
-            <a:avLst/>
-          </a:prstGeom>
-          <a:solidFill xmlns:a="http://schemas.openxmlformats.org/drawingml/2006/main">
-            <a:srgbClr val="F3F5F8"/>
-          </a:solidFill>
+            <a:off x="990600" y="6934200"/>
+            <a:ext cx="3181350" cy="0"/>
+          </a:xfrm>
+          <a:prstGeom xmlns:a="http://schemas.openxmlformats.org/drawingml/2006/main" prst="line">
+            <a:avLst/>
+          </a:prstGeom>
+          <a:noFill xmlns:a="http://schemas.openxmlformats.org/drawingml/2006/main"/>
           <a:ln xmlns:a="http://schemas.openxmlformats.org/drawingml/2006/main" w="12700">
             <a:solidFill>
               <a:srgbClr val="8E8D88"/>
@@ -4722,131 +4823,159 @@
       </p:sp>
       <p:sp>
         <p:nvSpPr>
-          <p:cNvPr id="21" name="operating-fill-0"/>
+          <p:cNvPr id="24" name="event-period-1"/>
+          <p:cNvSpPr txBox="1"/>
+          <p:nvPr/>
+        </p:nvSpPr>
+        <p:spPr>
+          <a:xfrm xmlns:a="http://schemas.openxmlformats.org/drawingml/2006/main">
+            <a:off x="4343400" y="3162300"/>
+            <a:ext cx="3181350" cy="323850"/>
+          </a:xfrm>
+          <a:prstGeom xmlns:a="http://schemas.openxmlformats.org/drawingml/2006/main" prst="rect">
+            <a:avLst/>
+          </a:prstGeom>
+          <a:noFill xmlns:a="http://schemas.openxmlformats.org/drawingml/2006/main"/>
+          <a:ln xmlns:a="http://schemas.openxmlformats.org/drawingml/2006/main" w="0">
+            <a:noFill/>
+          </a:ln>
+        </p:spPr>
+        <p:txBody>
+          <a:bodyPr xmlns:a="http://schemas.openxmlformats.org/drawingml/2006/main" wrap="square" lIns="0" tIns="0" rIns="0" bIns="0" anchor="t"/>
+          <a:lstStyle xmlns:a="http://schemas.openxmlformats.org/drawingml/2006/main"/>
+          <a:p xmlns:a="http://schemas.openxmlformats.org/drawingml/2006/main">
+            <a:r>
+              <a:rPr lang="en-US" sz="2100" b="1">
+                <a:solidFill>
+                  <a:srgbClr val="222222"/>
+                </a:solidFill>
+                <a:latin typeface="Tahoma"/>
+                <a:ea typeface="Tahoma"/>
+              </a:rPr>
+              <a:t>2021</a:t>
+            </a:r>
+            <a:endParaRPr lang="en-US"/>
+          </a:p>
+        </p:txBody>
+      </p:sp>
+      <p:sp>
+        <p:nvSpPr>
+          <p:cNvPr id="25" name="event-title-1"/>
+          <p:cNvSpPr txBox="1"/>
+          <p:nvPr/>
+        </p:nvSpPr>
+        <p:spPr>
+          <a:xfrm xmlns:a="http://schemas.openxmlformats.org/drawingml/2006/main">
+            <a:off x="4343400" y="3562350"/>
+            <a:ext cx="3181350" cy="247650"/>
+          </a:xfrm>
+          <a:prstGeom xmlns:a="http://schemas.openxmlformats.org/drawingml/2006/main" prst="rect">
+            <a:avLst/>
+          </a:prstGeom>
+          <a:noFill xmlns:a="http://schemas.openxmlformats.org/drawingml/2006/main"/>
+          <a:ln xmlns:a="http://schemas.openxmlformats.org/drawingml/2006/main" w="0">
+            <a:noFill/>
+          </a:ln>
+        </p:spPr>
+        <p:txBody>
+          <a:bodyPr xmlns:a="http://schemas.openxmlformats.org/drawingml/2006/main" wrap="square" lIns="0" tIns="0" rIns="0" bIns="0" anchor="t"/>
+          <a:lstStyle xmlns:a="http://schemas.openxmlformats.org/drawingml/2006/main"/>
+          <a:p xmlns:a="http://schemas.openxmlformats.org/drawingml/2006/main">
+            <a:r>
+              <a:rPr lang="en-US" sz="1275" b="1">
+                <a:solidFill>
+                  <a:srgbClr val="222222"/>
+                </a:solidFill>
+                <a:latin typeface="Tahoma"/>
+                <a:ea typeface="Tahoma"/>
+              </a:rPr>
+              <a:t>Proof point</a:t>
+            </a:r>
+            <a:endParaRPr lang="en-US"/>
+          </a:p>
+        </p:txBody>
+      </p:sp>
+      <p:sp>
+        <p:nvSpPr>
+          <p:cNvPr id="26" name="event-text-1"/>
+          <p:cNvSpPr txBox="1"/>
+          <p:nvPr/>
+        </p:nvSpPr>
+        <p:spPr>
+          <a:xfrm xmlns:a="http://schemas.openxmlformats.org/drawingml/2006/main">
+            <a:off x="4343400" y="3905250"/>
+            <a:ext cx="3181350" cy="628650"/>
+          </a:xfrm>
+          <a:prstGeom xmlns:a="http://schemas.openxmlformats.org/drawingml/2006/main" prst="rect">
+            <a:avLst/>
+          </a:prstGeom>
+          <a:noFill xmlns:a="http://schemas.openxmlformats.org/drawingml/2006/main"/>
+          <a:ln xmlns:a="http://schemas.openxmlformats.org/drawingml/2006/main" w="0">
+            <a:noFill/>
+          </a:ln>
+        </p:spPr>
+        <p:txBody>
+          <a:bodyPr xmlns:a="http://schemas.openxmlformats.org/drawingml/2006/main" wrap="square" lIns="0" tIns="0" rIns="0" bIns="0" anchor="t"/>
+          <a:lstStyle xmlns:a="http://schemas.openxmlformats.org/drawingml/2006/main"/>
+          <a:p xmlns:a="http://schemas.openxmlformats.org/drawingml/2006/main">
+            <a:r>
+              <a:rPr lang="en-US" sz="1125">
+                <a:solidFill>
+                  <a:srgbClr val="8E8D88"/>
+                </a:solidFill>
+                <a:latin typeface="Tahoma"/>
+                <a:ea typeface="Tahoma"/>
+              </a:rPr>
+              <a:t>The repeatable practice earns a place in the annual rhythm.</a:t>
+            </a:r>
+            <a:endParaRPr lang="en-US"/>
+          </a:p>
+        </p:txBody>
+      </p:sp>
+      <p:pic>
+        <p:nvPicPr>
+          <p:cNvPr id="27" name="event-photo-1">
+            <a:extLst xmlns:a="http://schemas.openxmlformats.org/drawingml/2006/main">
+              <a:ext uri="{C183D7F6-B498-43B3-948B-1728B52AA6E4}">
+                <adec:decorative xmlns:adec="http://schemas.microsoft.com/office/drawing/2017/decorative" val="1"/>
+              </a:ext>
+            </a:extLst>
+          </p:cNvPr>
+          <p:cNvPicPr/>
+          <p:nvPr/>
+        </p:nvPicPr>
+        <p:blipFill>
+          <a:blip xmlns:r="http://schemas.openxmlformats.org/officeDocument/2006/relationships" xmlns:a="http://schemas.openxmlformats.org/drawingml/2006/main" r:embed="rIdOfficeKitImage083106afebc7d419_1"/>
+          <a:srcRect xmlns:a="http://schemas.openxmlformats.org/drawingml/2006/main" l="0" t="34001" r="0" b="34001"/>
+          <a:stretch xmlns:a="http://schemas.openxmlformats.org/drawingml/2006/main">
+            <a:fillRect/>
+          </a:stretch>
+        </p:blipFill>
+        <p:spPr>
+          <a:xfrm xmlns:a="http://schemas.openxmlformats.org/drawingml/2006/main">
+            <a:off x="4343400" y="4914900"/>
+            <a:ext cx="3181350" cy="1809750"/>
+          </a:xfrm>
+          <a:prstGeom xmlns:a="http://schemas.openxmlformats.org/drawingml/2006/main" prst="rect">
+            <a:avLst/>
+          </a:prstGeom>
+        </p:spPr>
+      </p:pic>
+      <p:sp>
+        <p:nvSpPr>
+          <p:cNvPr id="28" name="event-rule-1"/>
           <p:cNvSpPr/>
           <p:nvPr/>
         </p:nvSpPr>
         <p:spPr>
           <a:xfrm xmlns:a="http://schemas.openxmlformats.org/drawingml/2006/main">
-            <a:off x="1104900" y="3848100"/>
-            <a:ext cx="1133475" cy="323850"/>
-          </a:xfrm>
-          <a:prstGeom xmlns:a="http://schemas.openxmlformats.org/drawingml/2006/main" prst="rect">
-            <a:avLst/>
-          </a:prstGeom>
-          <a:solidFill xmlns:a="http://schemas.openxmlformats.org/drawingml/2006/main">
-            <a:srgbClr val="B7A530"/>
-          </a:solidFill>
-          <a:ln xmlns:a="http://schemas.openxmlformats.org/drawingml/2006/main" w="0">
-            <a:solidFill>
-              <a:srgbClr val="B7A530"/>
-            </a:solidFill>
-            <a:prstDash val="solid"/>
-          </a:ln>
-        </p:spPr>
-        <p:txBody>
-          <a:bodyPr xmlns:a="http://schemas.openxmlformats.org/drawingml/2006/main" wrap="square" lIns="0" tIns="0" rIns="0" bIns="0" anchor="t"/>
-          <a:lstStyle xmlns:a="http://schemas.openxmlformats.org/drawingml/2006/main"/>
-          <a:p xmlns:a="http://schemas.openxmlformats.org/drawingml/2006/main">
-            <a:r>
-              <a:rPr lang="en-US"/>
-              <a:t/>
-            </a:r>
-            <a:endParaRPr lang="en-US"/>
-          </a:p>
-        </p:txBody>
-      </p:sp>
-      <p:sp>
-        <p:nvSpPr>
-          <p:cNvPr id="22" name="operating-value-0"/>
-          <p:cNvSpPr txBox="1"/>
-          <p:nvPr/>
-        </p:nvSpPr>
-        <p:spPr>
-          <a:xfrm xmlns:a="http://schemas.openxmlformats.org/drawingml/2006/main">
-            <a:off x="1104900" y="4400550"/>
-            <a:ext cx="2095500" cy="419100"/>
-          </a:xfrm>
-          <a:prstGeom xmlns:a="http://schemas.openxmlformats.org/drawingml/2006/main" prst="rect">
-            <a:avLst/>
-          </a:prstGeom>
-          <a:noFill xmlns:a="http://schemas.openxmlformats.org/drawingml/2006/main"/>
-          <a:ln xmlns:a="http://schemas.openxmlformats.org/drawingml/2006/main" w="0">
-            <a:noFill/>
-          </a:ln>
-        </p:spPr>
-        <p:txBody>
-          <a:bodyPr xmlns:a="http://schemas.openxmlformats.org/drawingml/2006/main" wrap="square" lIns="0" tIns="0" rIns="0" bIns="0" anchor="t"/>
-          <a:lstStyle xmlns:a="http://schemas.openxmlformats.org/drawingml/2006/main"/>
-          <a:p xmlns:a="http://schemas.openxmlformats.org/drawingml/2006/main">
-            <a:r>
-              <a:rPr lang="en-US" sz="2250" b="1">
-                <a:solidFill>
-                  <a:srgbClr val="222222"/>
-                </a:solidFill>
-                <a:latin typeface="Tahoma"/>
-                <a:ea typeface="Tahoma"/>
-              </a:rPr>
-              <a:t>54%</a:t>
-            </a:r>
-            <a:endParaRPr lang="en-US"/>
-          </a:p>
-        </p:txBody>
-      </p:sp>
-      <p:sp>
-        <p:nvSpPr>
-          <p:cNvPr id="23" name="operating-label-1"/>
-          <p:cNvSpPr txBox="1"/>
-          <p:nvPr/>
-        </p:nvSpPr>
-        <p:spPr>
-          <a:xfrm xmlns:a="http://schemas.openxmlformats.org/drawingml/2006/main">
-            <a:off x="3790950" y="3333750"/>
-            <a:ext cx="1809750" cy="228600"/>
-          </a:xfrm>
-          <a:prstGeom xmlns:a="http://schemas.openxmlformats.org/drawingml/2006/main" prst="rect">
-            <a:avLst/>
-          </a:prstGeom>
-          <a:noFill xmlns:a="http://schemas.openxmlformats.org/drawingml/2006/main"/>
-          <a:ln xmlns:a="http://schemas.openxmlformats.org/drawingml/2006/main" w="0">
-            <a:noFill/>
-          </a:ln>
-        </p:spPr>
-        <p:txBody>
-          <a:bodyPr xmlns:a="http://schemas.openxmlformats.org/drawingml/2006/main" wrap="square" lIns="0" tIns="0" rIns="0" bIns="0" anchor="t"/>
-          <a:lstStyle xmlns:a="http://schemas.openxmlformats.org/drawingml/2006/main"/>
-          <a:p xmlns:a="http://schemas.openxmlformats.org/drawingml/2006/main">
-            <a:r>
-              <a:rPr lang="en-US" sz="1125" b="1">
-                <a:solidFill>
-                  <a:srgbClr val="8E8D88"/>
-                </a:solidFill>
-                <a:latin typeface="Tahoma"/>
-                <a:ea typeface="Tahoma"/>
-              </a:rPr>
-              <a:t>TARGET</a:t>
-            </a:r>
-            <a:endParaRPr lang="en-US"/>
-          </a:p>
-        </p:txBody>
-      </p:sp>
-      <p:sp>
-        <p:nvSpPr>
-          <p:cNvPr id="24" name="operating-bar-1"/>
-          <p:cNvSpPr/>
-          <p:nvPr/>
-        </p:nvSpPr>
-        <p:spPr>
-          <a:xfrm xmlns:a="http://schemas.openxmlformats.org/drawingml/2006/main">
-            <a:off x="3790950" y="3848100"/>
-            <a:ext cx="2095500" cy="323850"/>
-          </a:xfrm>
-          <a:prstGeom xmlns:a="http://schemas.openxmlformats.org/drawingml/2006/main" prst="rect">
-            <a:avLst/>
-          </a:prstGeom>
-          <a:solidFill xmlns:a="http://schemas.openxmlformats.org/drawingml/2006/main">
-            <a:srgbClr val="F3F5F8"/>
-          </a:solidFill>
+            <a:off x="4343400" y="6934200"/>
+            <a:ext cx="3181350" cy="0"/>
+          </a:xfrm>
+          <a:prstGeom xmlns:a="http://schemas.openxmlformats.org/drawingml/2006/main" prst="line">
+            <a:avLst/>
+          </a:prstGeom>
+          <a:noFill xmlns:a="http://schemas.openxmlformats.org/drawingml/2006/main"/>
           <a:ln xmlns:a="http://schemas.openxmlformats.org/drawingml/2006/main" w="12700">
             <a:solidFill>
               <a:srgbClr val="8E8D88"/>
@@ -4868,131 +4997,159 @@
       </p:sp>
       <p:sp>
         <p:nvSpPr>
-          <p:cNvPr id="25" name="operating-fill-1"/>
+          <p:cNvPr id="29" name="event-period-2"/>
+          <p:cNvSpPr txBox="1"/>
+          <p:nvPr/>
+        </p:nvSpPr>
+        <p:spPr>
+          <a:xfrm xmlns:a="http://schemas.openxmlformats.org/drawingml/2006/main">
+            <a:off x="7696200" y="3162300"/>
+            <a:ext cx="3181350" cy="323850"/>
+          </a:xfrm>
+          <a:prstGeom xmlns:a="http://schemas.openxmlformats.org/drawingml/2006/main" prst="rect">
+            <a:avLst/>
+          </a:prstGeom>
+          <a:noFill xmlns:a="http://schemas.openxmlformats.org/drawingml/2006/main"/>
+          <a:ln xmlns:a="http://schemas.openxmlformats.org/drawingml/2006/main" w="0">
+            <a:noFill/>
+          </a:ln>
+        </p:spPr>
+        <p:txBody>
+          <a:bodyPr xmlns:a="http://schemas.openxmlformats.org/drawingml/2006/main" wrap="square" lIns="0" tIns="0" rIns="0" bIns="0" anchor="t"/>
+          <a:lstStyle xmlns:a="http://schemas.openxmlformats.org/drawingml/2006/main"/>
+          <a:p xmlns:a="http://schemas.openxmlformats.org/drawingml/2006/main">
+            <a:r>
+              <a:rPr lang="en-US" sz="2100" b="1">
+                <a:solidFill>
+                  <a:srgbClr val="222222"/>
+                </a:solidFill>
+                <a:latin typeface="Tahoma"/>
+                <a:ea typeface="Tahoma"/>
+              </a:rPr>
+              <a:t>2023</a:t>
+            </a:r>
+            <a:endParaRPr lang="en-US"/>
+          </a:p>
+        </p:txBody>
+      </p:sp>
+      <p:sp>
+        <p:nvSpPr>
+          <p:cNvPr id="30" name="event-title-2"/>
+          <p:cNvSpPr txBox="1"/>
+          <p:nvPr/>
+        </p:nvSpPr>
+        <p:spPr>
+          <a:xfrm xmlns:a="http://schemas.openxmlformats.org/drawingml/2006/main">
+            <a:off x="7696200" y="3562350"/>
+            <a:ext cx="3181350" cy="247650"/>
+          </a:xfrm>
+          <a:prstGeom xmlns:a="http://schemas.openxmlformats.org/drawingml/2006/main" prst="rect">
+            <a:avLst/>
+          </a:prstGeom>
+          <a:noFill xmlns:a="http://schemas.openxmlformats.org/drawingml/2006/main"/>
+          <a:ln xmlns:a="http://schemas.openxmlformats.org/drawingml/2006/main" w="0">
+            <a:noFill/>
+          </a:ln>
+        </p:spPr>
+        <p:txBody>
+          <a:bodyPr xmlns:a="http://schemas.openxmlformats.org/drawingml/2006/main" wrap="square" lIns="0" tIns="0" rIns="0" bIns="0" anchor="t"/>
+          <a:lstStyle xmlns:a="http://schemas.openxmlformats.org/drawingml/2006/main"/>
+          <a:p xmlns:a="http://schemas.openxmlformats.org/drawingml/2006/main">
+            <a:r>
+              <a:rPr lang="en-US" sz="1275" b="1">
+                <a:solidFill>
+                  <a:srgbClr val="222222"/>
+                </a:solidFill>
+                <a:latin typeface="Tahoma"/>
+                <a:ea typeface="Tahoma"/>
+              </a:rPr>
+              <a:t>Scale</a:t>
+            </a:r>
+            <a:endParaRPr lang="en-US"/>
+          </a:p>
+        </p:txBody>
+      </p:sp>
+      <p:sp>
+        <p:nvSpPr>
+          <p:cNvPr id="31" name="event-text-2"/>
+          <p:cNvSpPr txBox="1"/>
+          <p:nvPr/>
+        </p:nvSpPr>
+        <p:spPr>
+          <a:xfrm xmlns:a="http://schemas.openxmlformats.org/drawingml/2006/main">
+            <a:off x="7696200" y="3905250"/>
+            <a:ext cx="3181350" cy="628650"/>
+          </a:xfrm>
+          <a:prstGeom xmlns:a="http://schemas.openxmlformats.org/drawingml/2006/main" prst="rect">
+            <a:avLst/>
+          </a:prstGeom>
+          <a:noFill xmlns:a="http://schemas.openxmlformats.org/drawingml/2006/main"/>
+          <a:ln xmlns:a="http://schemas.openxmlformats.org/drawingml/2006/main" w="0">
+            <a:noFill/>
+          </a:ln>
+        </p:spPr>
+        <p:txBody>
+          <a:bodyPr xmlns:a="http://schemas.openxmlformats.org/drawingml/2006/main" wrap="square" lIns="0" tIns="0" rIns="0" bIns="0" anchor="t"/>
+          <a:lstStyle xmlns:a="http://schemas.openxmlformats.org/drawingml/2006/main"/>
+          <a:p xmlns:a="http://schemas.openxmlformats.org/drawingml/2006/main">
+            <a:r>
+              <a:rPr lang="en-US" sz="1125">
+                <a:solidFill>
+                  <a:srgbClr val="8E8D88"/>
+                </a:solidFill>
+                <a:latin typeface="Tahoma"/>
+                <a:ea typeface="Tahoma"/>
+              </a:rPr>
+              <a:t>The network grows without losing the original constraint.</a:t>
+            </a:r>
+            <a:endParaRPr lang="en-US"/>
+          </a:p>
+        </p:txBody>
+      </p:sp>
+      <p:pic>
+        <p:nvPicPr>
+          <p:cNvPr id="32" name="event-photo-2">
+            <a:extLst xmlns:a="http://schemas.openxmlformats.org/drawingml/2006/main">
+              <a:ext uri="{C183D7F6-B498-43B3-948B-1728B52AA6E4}">
+                <adec:decorative xmlns:adec="http://schemas.microsoft.com/office/drawing/2017/decorative" val="1"/>
+              </a:ext>
+            </a:extLst>
+          </p:cNvPr>
+          <p:cNvPicPr/>
+          <p:nvPr/>
+        </p:nvPicPr>
+        <p:blipFill>
+          <a:blip xmlns:r="http://schemas.openxmlformats.org/officeDocument/2006/relationships" xmlns:a="http://schemas.openxmlformats.org/drawingml/2006/main" r:embed="rIdOfficeKitImagebdd32fb5cfa65986_1"/>
+          <a:srcRect xmlns:a="http://schemas.openxmlformats.org/drawingml/2006/main" l="0" t="34001" r="0" b="34001"/>
+          <a:stretch xmlns:a="http://schemas.openxmlformats.org/drawingml/2006/main">
+            <a:fillRect/>
+          </a:stretch>
+        </p:blipFill>
+        <p:spPr>
+          <a:xfrm xmlns:a="http://schemas.openxmlformats.org/drawingml/2006/main">
+            <a:off x="7696200" y="4914900"/>
+            <a:ext cx="3181350" cy="1809750"/>
+          </a:xfrm>
+          <a:prstGeom xmlns:a="http://schemas.openxmlformats.org/drawingml/2006/main" prst="rect">
+            <a:avLst/>
+          </a:prstGeom>
+        </p:spPr>
+      </p:pic>
+      <p:sp>
+        <p:nvSpPr>
+          <p:cNvPr id="33" name="event-rule-2"/>
           <p:cNvSpPr/>
           <p:nvPr/>
         </p:nvSpPr>
         <p:spPr>
           <a:xfrm xmlns:a="http://schemas.openxmlformats.org/drawingml/2006/main">
-            <a:off x="3790950" y="3848100"/>
-            <a:ext cx="1590675" cy="323850"/>
-          </a:xfrm>
-          <a:prstGeom xmlns:a="http://schemas.openxmlformats.org/drawingml/2006/main" prst="rect">
-            <a:avLst/>
-          </a:prstGeom>
-          <a:solidFill xmlns:a="http://schemas.openxmlformats.org/drawingml/2006/main">
-            <a:srgbClr val="6B7E65"/>
-          </a:solidFill>
-          <a:ln xmlns:a="http://schemas.openxmlformats.org/drawingml/2006/main" w="0">
-            <a:solidFill>
-              <a:srgbClr val="6B7E65"/>
-            </a:solidFill>
-            <a:prstDash val="solid"/>
-          </a:ln>
-        </p:spPr>
-        <p:txBody>
-          <a:bodyPr xmlns:a="http://schemas.openxmlformats.org/drawingml/2006/main" wrap="square" lIns="0" tIns="0" rIns="0" bIns="0" anchor="t"/>
-          <a:lstStyle xmlns:a="http://schemas.openxmlformats.org/drawingml/2006/main"/>
-          <a:p xmlns:a="http://schemas.openxmlformats.org/drawingml/2006/main">
-            <a:r>
-              <a:rPr lang="en-US"/>
-              <a:t/>
-            </a:r>
-            <a:endParaRPr lang="en-US"/>
-          </a:p>
-        </p:txBody>
-      </p:sp>
-      <p:sp>
-        <p:nvSpPr>
-          <p:cNvPr id="26" name="operating-value-1"/>
-          <p:cNvSpPr txBox="1"/>
-          <p:nvPr/>
-        </p:nvSpPr>
-        <p:spPr>
-          <a:xfrm xmlns:a="http://schemas.openxmlformats.org/drawingml/2006/main">
-            <a:off x="3790950" y="4400550"/>
-            <a:ext cx="2095500" cy="419100"/>
-          </a:xfrm>
-          <a:prstGeom xmlns:a="http://schemas.openxmlformats.org/drawingml/2006/main" prst="rect">
-            <a:avLst/>
-          </a:prstGeom>
-          <a:noFill xmlns:a="http://schemas.openxmlformats.org/drawingml/2006/main"/>
-          <a:ln xmlns:a="http://schemas.openxmlformats.org/drawingml/2006/main" w="0">
-            <a:noFill/>
-          </a:ln>
-        </p:spPr>
-        <p:txBody>
-          <a:bodyPr xmlns:a="http://schemas.openxmlformats.org/drawingml/2006/main" wrap="square" lIns="0" tIns="0" rIns="0" bIns="0" anchor="t"/>
-          <a:lstStyle xmlns:a="http://schemas.openxmlformats.org/drawingml/2006/main"/>
-          <a:p xmlns:a="http://schemas.openxmlformats.org/drawingml/2006/main">
-            <a:r>
-              <a:rPr lang="en-US" sz="2250" b="1">
-                <a:solidFill>
-                  <a:srgbClr val="222222"/>
-                </a:solidFill>
-                <a:latin typeface="Tahoma"/>
-                <a:ea typeface="Tahoma"/>
-              </a:rPr>
-              <a:t>76%</a:t>
-            </a:r>
-            <a:endParaRPr lang="en-US"/>
-          </a:p>
-        </p:txBody>
-      </p:sp>
-      <p:sp>
-        <p:nvSpPr>
-          <p:cNvPr id="27" name="operating-label-2"/>
-          <p:cNvSpPr txBox="1"/>
-          <p:nvPr/>
-        </p:nvSpPr>
-        <p:spPr>
-          <a:xfrm xmlns:a="http://schemas.openxmlformats.org/drawingml/2006/main">
-            <a:off x="6477000" y="3333750"/>
-            <a:ext cx="1809750" cy="228600"/>
-          </a:xfrm>
-          <a:prstGeom xmlns:a="http://schemas.openxmlformats.org/drawingml/2006/main" prst="rect">
-            <a:avLst/>
-          </a:prstGeom>
-          <a:noFill xmlns:a="http://schemas.openxmlformats.org/drawingml/2006/main"/>
-          <a:ln xmlns:a="http://schemas.openxmlformats.org/drawingml/2006/main" w="0">
-            <a:noFill/>
-          </a:ln>
-        </p:spPr>
-        <p:txBody>
-          <a:bodyPr xmlns:a="http://schemas.openxmlformats.org/drawingml/2006/main" wrap="square" lIns="0" tIns="0" rIns="0" bIns="0" anchor="t"/>
-          <a:lstStyle xmlns:a="http://schemas.openxmlformats.org/drawingml/2006/main"/>
-          <a:p xmlns:a="http://schemas.openxmlformats.org/drawingml/2006/main">
-            <a:r>
-              <a:rPr lang="en-US" sz="1125" b="1">
-                <a:solidFill>
-                  <a:srgbClr val="8E8D88"/>
-                </a:solidFill>
-                <a:latin typeface="Tahoma"/>
-                <a:ea typeface="Tahoma"/>
-              </a:rPr>
-              <a:t>GAP</a:t>
-            </a:r>
-            <a:endParaRPr lang="en-US"/>
-          </a:p>
-        </p:txBody>
-      </p:sp>
-      <p:sp>
-        <p:nvSpPr>
-          <p:cNvPr id="28" name="operating-bar-2"/>
-          <p:cNvSpPr/>
-          <p:nvPr/>
-        </p:nvSpPr>
-        <p:spPr>
-          <a:xfrm xmlns:a="http://schemas.openxmlformats.org/drawingml/2006/main">
-            <a:off x="6477000" y="3848100"/>
-            <a:ext cx="2095500" cy="323850"/>
-          </a:xfrm>
-          <a:prstGeom xmlns:a="http://schemas.openxmlformats.org/drawingml/2006/main" prst="rect">
-            <a:avLst/>
-          </a:prstGeom>
-          <a:solidFill xmlns:a="http://schemas.openxmlformats.org/drawingml/2006/main">
-            <a:srgbClr val="F3F5F8"/>
-          </a:solidFill>
+            <a:off x="7696200" y="6934200"/>
+            <a:ext cx="3181350" cy="0"/>
+          </a:xfrm>
+          <a:prstGeom xmlns:a="http://schemas.openxmlformats.org/drawingml/2006/main" prst="line">
+            <a:avLst/>
+          </a:prstGeom>
+          <a:noFill xmlns:a="http://schemas.openxmlformats.org/drawingml/2006/main"/>
           <a:ln xmlns:a="http://schemas.openxmlformats.org/drawingml/2006/main" w="12700">
             <a:solidFill>
               <a:srgbClr val="8E8D88"/>
@@ -5014,24 +5171,162 @@
       </p:sp>
       <p:sp>
         <p:nvSpPr>
-          <p:cNvPr id="29" name="operating-fill-2"/>
+          <p:cNvPr id="34" name="event-period-3"/>
+          <p:cNvSpPr txBox="1"/>
+          <p:nvPr/>
+        </p:nvSpPr>
+        <p:spPr>
+          <a:xfrm xmlns:a="http://schemas.openxmlformats.org/drawingml/2006/main">
+            <a:off x="11049000" y="3162300"/>
+            <a:ext cx="3181350" cy="323850"/>
+          </a:xfrm>
+          <a:prstGeom xmlns:a="http://schemas.openxmlformats.org/drawingml/2006/main" prst="rect">
+            <a:avLst/>
+          </a:prstGeom>
+          <a:noFill xmlns:a="http://schemas.openxmlformats.org/drawingml/2006/main"/>
+          <a:ln xmlns:a="http://schemas.openxmlformats.org/drawingml/2006/main" w="0">
+            <a:noFill/>
+          </a:ln>
+        </p:spPr>
+        <p:txBody>
+          <a:bodyPr xmlns:a="http://schemas.openxmlformats.org/drawingml/2006/main" wrap="square" lIns="0" tIns="0" rIns="0" bIns="0" anchor="t"/>
+          <a:lstStyle xmlns:a="http://schemas.openxmlformats.org/drawingml/2006/main"/>
+          <a:p xmlns:a="http://schemas.openxmlformats.org/drawingml/2006/main">
+            <a:r>
+              <a:rPr lang="en-US" sz="2100" b="1">
+                <a:solidFill>
+                  <a:srgbClr val="B7A530"/>
+                </a:solidFill>
+                <a:latin typeface="Tahoma"/>
+                <a:ea typeface="Tahoma"/>
+              </a:rPr>
+              <a:t>2025</a:t>
+            </a:r>
+            <a:endParaRPr lang="en-US"/>
+          </a:p>
+        </p:txBody>
+      </p:sp>
+      <p:sp>
+        <p:nvSpPr>
+          <p:cNvPr id="35" name="event-title-3"/>
+          <p:cNvSpPr txBox="1"/>
+          <p:nvPr/>
+        </p:nvSpPr>
+        <p:spPr>
+          <a:xfrm xmlns:a="http://schemas.openxmlformats.org/drawingml/2006/main">
+            <a:off x="11049000" y="3562350"/>
+            <a:ext cx="3181350" cy="247650"/>
+          </a:xfrm>
+          <a:prstGeom xmlns:a="http://schemas.openxmlformats.org/drawingml/2006/main" prst="rect">
+            <a:avLst/>
+          </a:prstGeom>
+          <a:noFill xmlns:a="http://schemas.openxmlformats.org/drawingml/2006/main"/>
+          <a:ln xmlns:a="http://schemas.openxmlformats.org/drawingml/2006/main" w="0">
+            <a:noFill/>
+          </a:ln>
+        </p:spPr>
+        <p:txBody>
+          <a:bodyPr xmlns:a="http://schemas.openxmlformats.org/drawingml/2006/main" wrap="square" lIns="0" tIns="0" rIns="0" bIns="0" anchor="t"/>
+          <a:lstStyle xmlns:a="http://schemas.openxmlformats.org/drawingml/2006/main"/>
+          <a:p xmlns:a="http://schemas.openxmlformats.org/drawingml/2006/main">
+            <a:r>
+              <a:rPr lang="en-US" sz="1275" b="1">
+                <a:solidFill>
+                  <a:srgbClr val="222222"/>
+                </a:solidFill>
+                <a:latin typeface="Tahoma"/>
+                <a:ea typeface="Tahoma"/>
+              </a:rPr>
+              <a:t>Next chapter</a:t>
+            </a:r>
+            <a:endParaRPr lang="en-US"/>
+          </a:p>
+        </p:txBody>
+      </p:sp>
+      <p:sp>
+        <p:nvSpPr>
+          <p:cNvPr id="36" name="event-text-3"/>
+          <p:cNvSpPr txBox="1"/>
+          <p:nvPr/>
+        </p:nvSpPr>
+        <p:spPr>
+          <a:xfrm xmlns:a="http://schemas.openxmlformats.org/drawingml/2006/main">
+            <a:off x="11049000" y="3905250"/>
+            <a:ext cx="3181350" cy="628650"/>
+          </a:xfrm>
+          <a:prstGeom xmlns:a="http://schemas.openxmlformats.org/drawingml/2006/main" prst="rect">
+            <a:avLst/>
+          </a:prstGeom>
+          <a:noFill xmlns:a="http://schemas.openxmlformats.org/drawingml/2006/main"/>
+          <a:ln xmlns:a="http://schemas.openxmlformats.org/drawingml/2006/main" w="0">
+            <a:noFill/>
+          </a:ln>
+        </p:spPr>
+        <p:txBody>
+          <a:bodyPr xmlns:a="http://schemas.openxmlformats.org/drawingml/2006/main" wrap="square" lIns="0" tIns="0" rIns="0" bIns="0" anchor="t"/>
+          <a:lstStyle xmlns:a="http://schemas.openxmlformats.org/drawingml/2006/main"/>
+          <a:p xmlns:a="http://schemas.openxmlformats.org/drawingml/2006/main">
+            <a:r>
+              <a:rPr lang="en-US" sz="1125">
+                <a:solidFill>
+                  <a:srgbClr val="8E8D88"/>
+                </a:solidFill>
+                <a:latin typeface="Tahoma"/>
+                <a:ea typeface="Tahoma"/>
+              </a:rPr>
+              <a:t>The next period turns evidence into one bounded move.</a:t>
+            </a:r>
+            <a:endParaRPr lang="en-US"/>
+          </a:p>
+        </p:txBody>
+      </p:sp>
+      <p:pic>
+        <p:nvPicPr>
+          <p:cNvPr id="37" name="event-photo-3">
+            <a:extLst xmlns:a="http://schemas.openxmlformats.org/drawingml/2006/main">
+              <a:ext uri="{C183D7F6-B498-43B3-948B-1728B52AA6E4}">
+                <adec:decorative xmlns:adec="http://schemas.microsoft.com/office/drawing/2017/decorative" val="1"/>
+              </a:ext>
+            </a:extLst>
+          </p:cNvPr>
+          <p:cNvPicPr/>
+          <p:nvPr/>
+        </p:nvPicPr>
+        <p:blipFill>
+          <a:blip xmlns:r="http://schemas.openxmlformats.org/officeDocument/2006/relationships" xmlns:a="http://schemas.openxmlformats.org/drawingml/2006/main" r:embed="rIdOfficeKitImage092dd3ee80187530_1"/>
+          <a:srcRect xmlns:a="http://schemas.openxmlformats.org/drawingml/2006/main" l="0" t="34001" r="0" b="34001"/>
+          <a:stretch xmlns:a="http://schemas.openxmlformats.org/drawingml/2006/main">
+            <a:fillRect/>
+          </a:stretch>
+        </p:blipFill>
+        <p:spPr>
+          <a:xfrm xmlns:a="http://schemas.openxmlformats.org/drawingml/2006/main">
+            <a:off x="11049000" y="4914900"/>
+            <a:ext cx="3181350" cy="1809750"/>
+          </a:xfrm>
+          <a:prstGeom xmlns:a="http://schemas.openxmlformats.org/drawingml/2006/main" prst="rect">
+            <a:avLst/>
+          </a:prstGeom>
+        </p:spPr>
+      </p:pic>
+      <p:sp>
+        <p:nvSpPr>
+          <p:cNvPr id="38" name="event-rule-3"/>
           <p:cNvSpPr/>
           <p:nvPr/>
         </p:nvSpPr>
         <p:spPr>
           <a:xfrm xmlns:a="http://schemas.openxmlformats.org/drawingml/2006/main">
-            <a:off x="6477000" y="3848100"/>
-            <a:ext cx="457200" cy="323850"/>
-          </a:xfrm>
-          <a:prstGeom xmlns:a="http://schemas.openxmlformats.org/drawingml/2006/main" prst="rect">
-            <a:avLst/>
-          </a:prstGeom>
-          <a:solidFill xmlns:a="http://schemas.openxmlformats.org/drawingml/2006/main">
-            <a:srgbClr val="222222"/>
-          </a:solidFill>
-          <a:ln xmlns:a="http://schemas.openxmlformats.org/drawingml/2006/main" w="0">
+            <a:off x="11049000" y="6934200"/>
+            <a:ext cx="3181350" cy="0"/>
+          </a:xfrm>
+          <a:prstGeom xmlns:a="http://schemas.openxmlformats.org/drawingml/2006/main" prst="line">
+            <a:avLst/>
+          </a:prstGeom>
+          <a:noFill xmlns:a="http://schemas.openxmlformats.org/drawingml/2006/main"/>
+          <a:ln xmlns:a="http://schemas.openxmlformats.org/drawingml/2006/main" w="25400">
             <a:solidFill>
-              <a:srgbClr val="222222"/>
+              <a:srgbClr val="B7A530"/>
             </a:solidFill>
             <a:prstDash val="solid"/>
           </a:ln>
@@ -5050,226 +5345,44 @@
       </p:sp>
       <p:sp>
         <p:nvSpPr>
-          <p:cNvPr id="30" name="operating-value-2"/>
-          <p:cNvSpPr txBox="1"/>
-          <p:nvPr/>
-        </p:nvSpPr>
-        <p:spPr>
-          <a:xfrm xmlns:a="http://schemas.openxmlformats.org/drawingml/2006/main">
-            <a:off x="6477000" y="4400550"/>
-            <a:ext cx="2095500" cy="419100"/>
-          </a:xfrm>
-          <a:prstGeom xmlns:a="http://schemas.openxmlformats.org/drawingml/2006/main" prst="rect">
-            <a:avLst/>
-          </a:prstGeom>
-          <a:noFill xmlns:a="http://schemas.openxmlformats.org/drawingml/2006/main"/>
-          <a:ln xmlns:a="http://schemas.openxmlformats.org/drawingml/2006/main" w="0">
-            <a:noFill/>
-          </a:ln>
-        </p:spPr>
-        <p:txBody>
-          <a:bodyPr xmlns:a="http://schemas.openxmlformats.org/drawingml/2006/main" wrap="square" lIns="0" tIns="0" rIns="0" bIns="0" anchor="t"/>
-          <a:lstStyle xmlns:a="http://schemas.openxmlformats.org/drawingml/2006/main"/>
-          <a:p xmlns:a="http://schemas.openxmlformats.org/drawingml/2006/main">
-            <a:r>
-              <a:rPr lang="en-US" sz="2250" b="1">
-                <a:solidFill>
-                  <a:srgbClr val="222222"/>
-                </a:solidFill>
-                <a:latin typeface="Tahoma"/>
-                <a:ea typeface="Tahoma"/>
-              </a:rPr>
-              <a:t>22%</a:t>
-            </a:r>
-            <a:endParaRPr lang="en-US"/>
-          </a:p>
-        </p:txBody>
-      </p:sp>
-      <p:sp>
-        <p:nvSpPr>
-          <p:cNvPr id="31" name="operating-axis"/>
-          <p:cNvSpPr/>
-          <p:nvPr/>
-        </p:nvSpPr>
-        <p:spPr>
-          <a:xfrm xmlns:a="http://schemas.openxmlformats.org/drawingml/2006/main">
-            <a:off x="1104900" y="5334000"/>
-            <a:ext cx="7486650" cy="0"/>
-          </a:xfrm>
-          <a:prstGeom xmlns:a="http://schemas.openxmlformats.org/drawingml/2006/main" prst="line">
-            <a:avLst/>
-          </a:prstGeom>
-          <a:noFill xmlns:a="http://schemas.openxmlformats.org/drawingml/2006/main"/>
-          <a:ln xmlns:a="http://schemas.openxmlformats.org/drawingml/2006/main" w="25400">
-            <a:solidFill>
-              <a:srgbClr val="8E8D88"/>
-            </a:solidFill>
-            <a:prstDash val="solid"/>
-          </a:ln>
-        </p:spPr>
-        <p:txBody>
-          <a:bodyPr xmlns:a="http://schemas.openxmlformats.org/drawingml/2006/main" wrap="square" lIns="0" tIns="0" rIns="0" bIns="0" anchor="t"/>
-          <a:lstStyle xmlns:a="http://schemas.openxmlformats.org/drawingml/2006/main"/>
-          <a:p xmlns:a="http://schemas.openxmlformats.org/drawingml/2006/main">
-            <a:r>
-              <a:rPr lang="en-US"/>
-              <a:t/>
-            </a:r>
-            <a:endParaRPr lang="en-US"/>
-          </a:p>
-        </p:txBody>
-      </p:sp>
-      <p:sp>
-        <p:nvSpPr>
-          <p:cNvPr id="32" name="operating-read"/>
-          <p:cNvSpPr txBox="1"/>
-          <p:nvPr/>
-        </p:nvSpPr>
-        <p:spPr>
-          <a:xfrm xmlns:a="http://schemas.openxmlformats.org/drawingml/2006/main">
-            <a:off x="1104900" y="5657850"/>
-            <a:ext cx="7524750" cy="342900"/>
-          </a:xfrm>
-          <a:prstGeom xmlns:a="http://schemas.openxmlformats.org/drawingml/2006/main" prst="rect">
-            <a:avLst/>
-          </a:prstGeom>
-          <a:noFill xmlns:a="http://schemas.openxmlformats.org/drawingml/2006/main"/>
-          <a:ln xmlns:a="http://schemas.openxmlformats.org/drawingml/2006/main" w="0">
-            <a:noFill/>
-          </a:ln>
-        </p:spPr>
-        <p:txBody>
-          <a:bodyPr xmlns:a="http://schemas.openxmlformats.org/drawingml/2006/main" wrap="square" lIns="0" tIns="0" rIns="0" bIns="0" anchor="t"/>
-          <a:lstStyle xmlns:a="http://schemas.openxmlformats.org/drawingml/2006/main"/>
-          <a:p xmlns:a="http://schemas.openxmlformats.org/drawingml/2006/main">
-            <a:r>
-              <a:rPr lang="en-US" sz="1800" b="1">
-                <a:solidFill>
-                  <a:srgbClr val="222222"/>
-                </a:solidFill>
-                <a:latin typeface="Tahoma"/>
-                <a:ea typeface="Tahoma"/>
-              </a:rPr>
-              <a:t>Status is useful only when the next handoff is visible.</a:t>
-            </a:r>
-            <a:endParaRPr lang="en-US"/>
-          </a:p>
-        </p:txBody>
-      </p:sp>
-      <p:sp>
-        <p:nvSpPr>
-          <p:cNvPr id="33" name="operating-note-label"/>
-          <p:cNvSpPr txBox="1"/>
-          <p:nvPr/>
-        </p:nvSpPr>
-        <p:spPr>
-          <a:xfrm xmlns:a="http://schemas.openxmlformats.org/drawingml/2006/main">
-            <a:off x="10287000" y="3333750"/>
-            <a:ext cx="2857500" cy="228600"/>
-          </a:xfrm>
-          <a:prstGeom xmlns:a="http://schemas.openxmlformats.org/drawingml/2006/main" prst="rect">
-            <a:avLst/>
-          </a:prstGeom>
-          <a:noFill xmlns:a="http://schemas.openxmlformats.org/drawingml/2006/main"/>
-          <a:ln xmlns:a="http://schemas.openxmlformats.org/drawingml/2006/main" w="0">
-            <a:noFill/>
-          </a:ln>
-        </p:spPr>
-        <p:txBody>
-          <a:bodyPr xmlns:a="http://schemas.openxmlformats.org/drawingml/2006/main" wrap="square" lIns="0" tIns="0" rIns="0" bIns="0" anchor="t"/>
-          <a:lstStyle xmlns:a="http://schemas.openxmlformats.org/drawingml/2006/main"/>
-          <a:p xmlns:a="http://schemas.openxmlformats.org/drawingml/2006/main">
-            <a:r>
-              <a:rPr lang="en-US" sz="1125" b="1">
-                <a:solidFill>
-                  <a:srgbClr val="B7A530"/>
-                </a:solidFill>
-                <a:latin typeface="Tahoma"/>
-                <a:ea typeface="Tahoma"/>
-              </a:rPr>
-              <a:t>EXCEPTION</a:t>
-            </a:r>
-            <a:endParaRPr lang="en-US"/>
-          </a:p>
-        </p:txBody>
-      </p:sp>
-      <p:sp>
-        <p:nvSpPr>
-          <p:cNvPr id="34" name="operating-note"/>
-          <p:cNvSpPr txBox="1"/>
-          <p:nvPr/>
-        </p:nvSpPr>
-        <p:spPr>
-          <a:xfrm xmlns:a="http://schemas.openxmlformats.org/drawingml/2006/main">
-            <a:off x="10287000" y="3829050"/>
-            <a:ext cx="3143250" cy="723900"/>
-          </a:xfrm>
-          <a:prstGeom xmlns:a="http://schemas.openxmlformats.org/drawingml/2006/main" prst="rect">
-            <a:avLst/>
-          </a:prstGeom>
-          <a:noFill xmlns:a="http://schemas.openxmlformats.org/drawingml/2006/main"/>
-          <a:ln xmlns:a="http://schemas.openxmlformats.org/drawingml/2006/main" w="0">
-            <a:noFill/>
-          </a:ln>
-        </p:spPr>
-        <p:txBody>
-          <a:bodyPr xmlns:a="http://schemas.openxmlformats.org/drawingml/2006/main" wrap="square" lIns="0" tIns="0" rIns="0" bIns="0" anchor="t"/>
-          <a:lstStyle xmlns:a="http://schemas.openxmlformats.org/drawingml/2006/main"/>
-          <a:p xmlns:a="http://schemas.openxmlformats.org/drawingml/2006/main">
-            <a:r>
-              <a:rPr lang="en-US" sz="2100" b="1">
-                <a:solidFill>
-                  <a:srgbClr val="222222"/>
-                </a:solidFill>
-                <a:latin typeface="Tahoma"/>
-                <a:ea typeface="Tahoma"/>
-              </a:rPr>
-              <a:t>The gap is not a decoration; it is the work.</a:t>
-            </a:r>
-            <a:endParaRPr lang="en-US"/>
-          </a:p>
-        </p:txBody>
-      </p:sp>
-      <p:sp>
-        <p:nvSpPr>
-          <p:cNvPr id="35" name="operating-note-foot"/>
-          <p:cNvSpPr txBox="1"/>
-          <p:nvPr/>
-        </p:nvSpPr>
-        <p:spPr>
-          <a:xfrm xmlns:a="http://schemas.openxmlformats.org/drawingml/2006/main">
-            <a:off x="10287000" y="5010150"/>
-            <a:ext cx="3143250" cy="457200"/>
-          </a:xfrm>
-          <a:prstGeom xmlns:a="http://schemas.openxmlformats.org/drawingml/2006/main" prst="rect">
-            <a:avLst/>
-          </a:prstGeom>
-          <a:noFill xmlns:a="http://schemas.openxmlformats.org/drawingml/2006/main"/>
-          <a:ln xmlns:a="http://schemas.openxmlformats.org/drawingml/2006/main" w="0">
-            <a:noFill/>
-          </a:ln>
-        </p:spPr>
-        <p:txBody>
-          <a:bodyPr xmlns:a="http://schemas.openxmlformats.org/drawingml/2006/main" wrap="square" lIns="0" tIns="0" rIns="0" bIns="0" anchor="t"/>
-          <a:lstStyle xmlns:a="http://schemas.openxmlformats.org/drawingml/2006/main"/>
-          <a:p xmlns:a="http://schemas.openxmlformats.org/drawingml/2006/main">
-            <a:r>
-              <a:rPr lang="en-US" sz="1275">
+          <p:cNvPr id="39" name="event-footnote"/>
+          <p:cNvSpPr txBox="1"/>
+          <p:nvPr/>
+        </p:nvSpPr>
+        <p:spPr>
+          <a:xfrm xmlns:a="http://schemas.openxmlformats.org/drawingml/2006/main">
+            <a:off x="990600" y="7239000"/>
+            <a:ext cx="10668000" cy="228600"/>
+          </a:xfrm>
+          <a:prstGeom xmlns:a="http://schemas.openxmlformats.org/drawingml/2006/main" prst="rect">
+            <a:avLst/>
+          </a:prstGeom>
+          <a:noFill xmlns:a="http://schemas.openxmlformats.org/drawingml/2006/main"/>
+          <a:ln xmlns:a="http://schemas.openxmlformats.org/drawingml/2006/main" w="0">
+            <a:noFill/>
+          </a:ln>
+        </p:spPr>
+        <p:txBody>
+          <a:bodyPr xmlns:a="http://schemas.openxmlformats.org/drawingml/2006/main" wrap="square" lIns="0" tIns="0" rIns="0" bIns="0" anchor="t"/>
+          <a:lstStyle xmlns:a="http://schemas.openxmlformats.org/drawingml/2006/main"/>
+          <a:p xmlns:a="http://schemas.openxmlformats.org/drawingml/2006/main">
+            <a:r>
+              <a:rPr lang="en-US" sz="1050">
                 <a:solidFill>
                   <a:srgbClr val="8E8D88"/>
                 </a:solidFill>
                 <a:latin typeface="Tahoma"/>
                 <a:ea typeface="Tahoma"/>
               </a:rPr>
-              <a:t>A healthy page names the owner and the next date.</a:t>
-            </a:r>
-            <a:endParaRPr lang="en-US"/>
-          </a:p>
-        </p:txBody>
-      </p:sp>
-      <p:sp>
-        <p:nvSpPr>
-          <p:cNvPr id="36" name="source"/>
+              <a:t>Event sequence · one image per milestone · source and period remain adjacent</a:t>
+            </a:r>
+            <a:endParaRPr lang="en-US"/>
+          </a:p>
+        </p:txBody>
+      </p:sp>
+      <p:sp>
+        <p:nvSpPr>
+          <p:cNvPr id="40" name="source"/>
           <p:cNvSpPr txBox="1"/>
           <p:nvPr/>
         </p:nvSpPr>
@@ -5306,7 +5419,7 @@
       </p:sp>
       <p:sp>
         <p:nvSpPr>
-          <p:cNvPr id="37" name="page-number"/>
+          <p:cNvPr id="41" name="page-number"/>
           <p:cNvSpPr txBox="1"/>
           <p:nvPr/>
         </p:nvSpPr>
@@ -5356,7 +5469,7 @@
     <p:bg>
       <p:bgPr>
         <a:blipFill xmlns:a="http://schemas.openxmlformats.org/drawingml/2006/main">
-          <a:blip xmlns:r="http://schemas.openxmlformats.org/officeDocument/2006/relationships" r:embed="rIdOfficeKitImage026be3a43029630d_1"/>
+          <a:blip xmlns:r="http://schemas.openxmlformats.org/officeDocument/2006/relationships" r:embed="rIdOfficeKitImage2930549abca3ae00_1"/>
           <a:stretch>
             <a:fillRect/>
           </a:stretch>

</xml_diff>